<commit_message>
Final deck (clean demo interstitial) + the group submission document
The demo slide is now a plain interstitial (the drop-in editing notes
are removed - the demo is cut into the video itself). Deck refreshed in
proposal/ and both submission-folder copies.

Adds Blockmediary_Main_Submission.pdf: the one-page group document the
brief requires, with clickable links to the video, the live prototype,
the public repo, the mainnet settlement transaction, and the testnet
contract.

Co-Authored-By: Claude Opus 5 <noreply@anthropic.com>
</commit_message>
<xml_diff>
--- a/docs/PDFs For Submission/Main-Presentation-Aug-14.pptx
+++ b/docs/PDFs For Submission/Main-Presentation-Aug-14.pptx
@@ -16524,53 +16524,6 @@
                 <a:latin typeface="Aptos"/>
               </a:rPr>
               <a:t>Recorded on Base Mainnet - real USDC, no simulation.</a:t>
-            </a:r>
-          </a:p>
-        </p:txBody>
-      </p:sp>
-      <p:sp>
-        <p:nvSpPr>
-          <p:cNvPr id="5" name="TextBox 4"/>
-          <p:cNvSpPr txBox="1"/>
-          <p:nvPr/>
-        </p:nvSpPr>
-        <p:spPr>
-          <a:xfrm>
-            <a:off x="822960" y="5120640"/>
-            <a:ext cx="10545775" cy="822960"/>
-          </a:xfrm>
-          <a:prstGeom prst="rect">
-            <a:avLst/>
-          </a:prstGeom>
-          <a:noFill/>
-        </p:spPr>
-        <p:txBody>
-          <a:bodyPr wrap="square">
-            <a:spAutoFit/>
-          </a:bodyPr>
-          <a:lstStyle/>
-          <a:p>
-            <a:pPr algn="l"/>
-            <a:r>
-              <a:rPr sz="1400" b="0" spc="200">
-                <a:solidFill>
-                  <a:srgbClr val="9CA6B8"/>
-                </a:solidFill>
-                <a:latin typeface="Aptos"/>
-              </a:rPr>
-              <a:t>[ DROP DEMO RECORDING HERE - approx. 2:00 ]</a:t>
-            </a:r>
-          </a:p>
-          <a:p>
-            <a:pPr algn="l"/>
-            <a:r>
-              <a:rPr sz="1100" b="0">
-                <a:solidFill>
-                  <a:srgbClr val="9CA6B8"/>
-                </a:solidFill>
-                <a:latin typeface="Aptos"/>
-              </a:rPr>
-              <a:t>Suggested cut: dashboard -&gt; agreed deal -&gt; buyer funds from own wallet -&gt; seller submits documents -&gt; verdict -&gt; release -&gt; BaseScan.</a:t>
             </a:r>
           </a:p>
         </p:txBody>

</xml_diff>